<commit_message>
Add more subtask for Day 1 homework
</commit_message>
<xml_diff>
--- a/заняття_1_python_core/презентація/python_для_web.pptx
+++ b/заняття_1_python_core/презентація/python_для_web.pptx
@@ -8081,8 +8081,23 @@
                 </a:solidFill>
                 <a:latin typeface="Calibri" pitchFamily="34" charset="0"/>
               </a:rPr>
-              <a:t>💼 Досвід</a:t>
-            </a:r>
+              <a:t>💼 </a:t>
+            </a:r>
+            <a:r>
+              <a:rPr lang="en-US" sz="1400" b="1" dirty="0" err="1">
+                <a:solidFill>
+                  <a:srgbClr val="F5A623"/>
+                </a:solidFill>
+                <a:latin typeface="Calibri" pitchFamily="34" charset="0"/>
+              </a:rPr>
+              <a:t>Досвід</a:t>
+            </a:r>
+            <a:endParaRPr lang="en-US" sz="1400" b="1" dirty="0">
+              <a:solidFill>
+                <a:srgbClr val="F5A623"/>
+              </a:solidFill>
+              <a:latin typeface="Calibri" pitchFamily="34" charset="0"/>
+            </a:endParaRPr>
           </a:p>
           <a:p>
             <a:pPr marL="0" indent="0">
@@ -8156,23 +8171,8 @@
                 </a:solidFill>
                 <a:latin typeface="Consolas" pitchFamily="34" charset="0"/>
               </a:rPr>
-              <a:t>@</a:t>
-            </a:r>
-            <a:r>
-              <a:rPr lang="en-US" sz="1200" dirty="0" err="1">
-                <a:solidFill>
-                  <a:srgbClr val="A8D8FF"/>
-                </a:solidFill>
-                <a:latin typeface="Consolas" pitchFamily="34" charset="0"/>
-              </a:rPr>
-              <a:t>dmitriy_shtefan</a:t>
-            </a:r>
-            <a:endParaRPr lang="en-US" sz="1200" dirty="0">
-              <a:solidFill>
-                <a:srgbClr val="A8D8FF"/>
-              </a:solidFill>
-              <a:latin typeface="Consolas" pitchFamily="34" charset="0"/>
-            </a:endParaRPr>
+              <a:t>@dmitriy_shtefan</a:t>
+            </a:r>
           </a:p>
           <a:p>
             <a:pPr marL="0" indent="0">
@@ -8198,40 +8198,13 @@
               </a:spcAft>
             </a:pPr>
             <a:r>
-              <a:rPr lang="en-US" sz="1200" dirty="0" err="1">
+              <a:rPr lang="en-US" sz="1200" dirty="0">
                 <a:solidFill>
                   <a:srgbClr val="A8D8FF"/>
                 </a:solidFill>
                 <a:latin typeface="Consolas" pitchFamily="34" charset="0"/>
               </a:rPr>
-              <a:t>linkedin.com</a:t>
-            </a:r>
-            <a:r>
-              <a:rPr lang="en-US" sz="1200" dirty="0">
-                <a:solidFill>
-                  <a:srgbClr val="A8D8FF"/>
-                </a:solidFill>
-                <a:latin typeface="Consolas" pitchFamily="34" charset="0"/>
-              </a:rPr>
-              <a:t>/in/</a:t>
-            </a:r>
-            <a:r>
-              <a:rPr lang="en-US" sz="1200" dirty="0" err="1">
-                <a:solidFill>
-                  <a:srgbClr val="A8D8FF"/>
-                </a:solidFill>
-                <a:latin typeface="Consolas" pitchFamily="34" charset="0"/>
-              </a:rPr>
-              <a:t>dmitry-shtefan</a:t>
-            </a:r>
-            <a:r>
-              <a:rPr lang="en-US" sz="1200" dirty="0">
-                <a:solidFill>
-                  <a:srgbClr val="A8D8FF"/>
-                </a:solidFill>
-                <a:latin typeface="Consolas" pitchFamily="34" charset="0"/>
-              </a:rPr>
-              <a:t>/</a:t>
+              <a:t>linkedin.com/in/dmitry-shtefan/</a:t>
             </a:r>
           </a:p>
         </p:txBody>

</xml_diff>

<commit_message>
Add empty sample script
</commit_message>
<xml_diff>
--- a/заняття_1_python_core/презентація/python_для_web.pptx
+++ b/заняття_1_python_core/презентація/python_для_web.pptx
@@ -3951,7 +3951,7 @@
         </p:nvSpPr>
         <p:spPr>
           <a:xfrm>
-            <a:off x="365760" y="4526280"/>
+            <a:off x="365760" y="4568952"/>
             <a:ext cx="8595360" cy="347472"/>
           </a:xfrm>
           <a:prstGeom prst="rect">
@@ -8081,23 +8081,8 @@
                 </a:solidFill>
                 <a:latin typeface="Calibri" pitchFamily="34" charset="0"/>
               </a:rPr>
-              <a:t>💼 </a:t>
-            </a:r>
-            <a:r>
-              <a:rPr lang="en-US" sz="1400" b="1" dirty="0" err="1">
-                <a:solidFill>
-                  <a:srgbClr val="F5A623"/>
-                </a:solidFill>
-                <a:latin typeface="Calibri" pitchFamily="34" charset="0"/>
-              </a:rPr>
-              <a:t>Досвід</a:t>
-            </a:r>
-            <a:endParaRPr lang="en-US" sz="1400" b="1" dirty="0">
-              <a:solidFill>
-                <a:srgbClr val="F5A623"/>
-              </a:solidFill>
-              <a:latin typeface="Calibri" pitchFamily="34" charset="0"/>
-            </a:endParaRPr>
+              <a:t>💼 Досвід</a:t>
+            </a:r>
           </a:p>
           <a:p>
             <a:pPr marL="0" indent="0">
@@ -13406,7 +13391,7 @@
                 </a:solidFill>
                 <a:latin typeface="Consolas" pitchFamily="34" charset="0"/>
               </a:rPr>
-              <a:t>  </a:t>
+              <a:t> </a:t>
             </a:r>
             <a:r>
               <a:rPr lang="en-US" sz="2200" b="1" dirty="0">
@@ -13690,7 +13675,7 @@
         </p:nvSpPr>
         <p:spPr>
           <a:xfrm>
-            <a:off x="4572000" y="1609344"/>
+            <a:off x="4650740" y="1618488"/>
             <a:ext cx="3931920" cy="1097280"/>
           </a:xfrm>
           <a:prstGeom prst="rect">
@@ -13835,8 +13820,8 @@
         </p:nvSpPr>
         <p:spPr>
           <a:xfrm>
-            <a:off x="274320" y="2761488"/>
-            <a:ext cx="8595360" cy="914400"/>
+            <a:off x="274320" y="2843784"/>
+            <a:ext cx="8595360" cy="1416812"/>
           </a:xfrm>
           <a:prstGeom prst="rect">
             <a:avLst/>
@@ -13867,8 +13852,8 @@
         </p:nvSpPr>
         <p:spPr>
           <a:xfrm>
-            <a:off x="365760" y="2852928"/>
-            <a:ext cx="8412480" cy="731520"/>
+            <a:off x="457200" y="2935224"/>
+            <a:ext cx="8412480" cy="1325372"/>
           </a:xfrm>
           <a:prstGeom prst="rect">
             <a:avLst/>
@@ -13880,9 +13865,6 @@
           <a:bodyPr wrap="square" lIns="0" tIns="0" rIns="0" bIns="0" rtlCol="0" anchor="t"/>
           <a:lstStyle/>
           <a:p>
-            <a:pPr marL="0" indent="0">
-              <a:buNone/>
-            </a:pPr>
             <a:r>
               <a:rPr lang="en-US" sz="1100" dirty="0">
                 <a:solidFill>
@@ -13890,13 +13872,19 @@
                 </a:solidFill>
                 <a:latin typeface="Consolas" pitchFamily="34" charset="0"/>
               </a:rPr>
-              <a:t># Підрахунок: кількість запитів по методу</a:t>
-            </a:r>
-          </a:p>
-          <a:p>
-            <a:pPr marL="0" indent="0">
-              <a:buNone/>
-            </a:pPr>
+              <a:t># </a:t>
+            </a:r>
+            <a:r>
+              <a:rPr lang="uk-UA" sz="1100" dirty="0">
+                <a:solidFill>
+                  <a:srgbClr val="A8D8FF"/>
+                </a:solidFill>
+                <a:latin typeface="Consolas" pitchFamily="34" charset="0"/>
+              </a:rPr>
+              <a:t>Безпечне отримання ролі</a:t>
+            </a:r>
+          </a:p>
+          <a:p>
             <a:r>
               <a:rPr lang="en-US" sz="1100" dirty="0">
                 <a:solidFill>
@@ -13904,13 +13892,41 @@
                 </a:solidFill>
                 <a:latin typeface="Consolas" pitchFamily="34" charset="0"/>
               </a:rPr>
-              <a:t>from collections import Counter</a:t>
-            </a:r>
-          </a:p>
-          <a:p>
-            <a:pPr marL="0" indent="0">
-              <a:buNone/>
-            </a:pPr>
+              <a:t>role = user.get("role", "guest")</a:t>
+            </a:r>
+            <a:br>
+              <a:rPr lang="ru-RU" sz="1100" dirty="0">
+                <a:solidFill>
+                  <a:srgbClr val="A8D8FF"/>
+                </a:solidFill>
+                <a:latin typeface="Consolas" pitchFamily="34" charset="0"/>
+              </a:rPr>
+            </a:br>
+            <a:br>
+              <a:rPr lang="ru-RU" sz="1100" dirty="0">
+                <a:solidFill>
+                  <a:srgbClr val="A8D8FF"/>
+                </a:solidFill>
+                <a:latin typeface="Consolas" pitchFamily="34" charset="0"/>
+              </a:rPr>
+            </a:br>
+            <a:r>
+              <a:rPr lang="ru-RU" sz="1100" dirty="0">
+                <a:solidFill>
+                  <a:srgbClr val="A8D8FF"/>
+                </a:solidFill>
+                <a:latin typeface="Consolas" pitchFamily="34" charset="0"/>
+              </a:rPr>
+              <a:t># Підрахунок загальної суми замовлень</a:t>
+            </a:r>
+            <a:br>
+              <a:rPr lang="ru-RU" sz="1100" dirty="0">
+                <a:solidFill>
+                  <a:srgbClr val="A8D8FF"/>
+                </a:solidFill>
+                <a:latin typeface="Consolas" pitchFamily="34" charset="0"/>
+              </a:rPr>
+            </a:br>
             <a:r>
               <a:rPr lang="en-US" sz="1100" dirty="0">
                 <a:solidFill>
@@ -13918,27 +13934,16 @@
                 </a:solidFill>
                 <a:latin typeface="Consolas" pitchFamily="34" charset="0"/>
               </a:rPr>
-              <a:t>counts = Counter(r['method'] for r in requests)</a:t>
-            </a:r>
-          </a:p>
-          <a:p>
-            <a:pPr marL="0" indent="0">
-              <a:buNone/>
-            </a:pPr>
-            <a:r>
+              <a:t>total_sum = 0</a:t>
+            </a:r>
+            <a:br>
               <a:rPr lang="en-US" sz="1100" dirty="0">
                 <a:solidFill>
                   <a:srgbClr val="A8D8FF"/>
                 </a:solidFill>
                 <a:latin typeface="Consolas" pitchFamily="34" charset="0"/>
               </a:rPr>
-              <a:t># або вручну:</a:t>
-            </a:r>
-          </a:p>
-          <a:p>
-            <a:pPr marL="0" indent="0">
-              <a:buNone/>
-            </a:pPr>
+            </a:br>
             <a:r>
               <a:rPr lang="en-US" sz="1100" dirty="0">
                 <a:solidFill>
@@ -13946,27 +13951,25 @@
                 </a:solidFill>
                 <a:latin typeface="Consolas" pitchFamily="34" charset="0"/>
               </a:rPr>
-              <a:t>counts = {}</a:t>
-            </a:r>
-          </a:p>
-          <a:p>
-            <a:pPr marL="0" indent="0">
-              <a:buNone/>
-            </a:pPr>
-            <a:r>
+              <a:t>for order in user["orders"]:</a:t>
+            </a:r>
+            <a:br>
               <a:rPr lang="en-US" sz="1100" dirty="0">
                 <a:solidFill>
                   <a:srgbClr val="A8D8FF"/>
                 </a:solidFill>
                 <a:latin typeface="Consolas" pitchFamily="34" charset="0"/>
               </a:rPr>
-              <a:t>for r in requests:</a:t>
-            </a:r>
-          </a:p>
-          <a:p>
-            <a:pPr marL="0" indent="0">
-              <a:buNone/>
-            </a:pPr>
+            </a:br>
+            <a:r>
+              <a:rPr lang="uk-UA" sz="1100" dirty="0">
+                <a:solidFill>
+                  <a:srgbClr val="A8D8FF"/>
+                </a:solidFill>
+                <a:latin typeface="Consolas" pitchFamily="34" charset="0"/>
+              </a:rPr>
+              <a:t>    </a:t>
+            </a:r>
             <a:r>
               <a:rPr lang="en-US" sz="1100" dirty="0">
                 <a:solidFill>
@@ -13974,8 +13977,22 @@
                 </a:solidFill>
                 <a:latin typeface="Consolas" pitchFamily="34" charset="0"/>
               </a:rPr>
-              <a:t>    counts[r['method']] = counts.get(r['method'], 0) + 1</a:t>
-            </a:r>
+              <a:t>total_sum += order["total"]</a:t>
+            </a:r>
+            <a:br>
+              <a:rPr lang="en-US" sz="1100" dirty="0">
+                <a:solidFill>
+                  <a:srgbClr val="A8D8FF"/>
+                </a:solidFill>
+                <a:latin typeface="Consolas" pitchFamily="34" charset="0"/>
+              </a:rPr>
+            </a:br>
+            <a:endParaRPr lang="en-US" sz="1100" dirty="0">
+              <a:solidFill>
+                <a:srgbClr val="A8D8FF"/>
+              </a:solidFill>
+              <a:latin typeface="Consolas" pitchFamily="34" charset="0"/>
+            </a:endParaRPr>
           </a:p>
         </p:txBody>
       </p:sp>
@@ -13987,7 +14004,7 @@
         </p:nvSpPr>
         <p:spPr>
           <a:xfrm>
-            <a:off x="274320" y="3669818"/>
+            <a:off x="274320" y="4356608"/>
             <a:ext cx="8595360" cy="347472"/>
           </a:xfrm>
           <a:prstGeom prst="rect">
@@ -14019,7 +14036,7 @@
         </p:nvSpPr>
         <p:spPr>
           <a:xfrm>
-            <a:off x="457200" y="3669818"/>
+            <a:off x="411480" y="4356608"/>
             <a:ext cx="8321040" cy="347472"/>
           </a:xfrm>
           <a:prstGeom prst="rect">

</xml_diff>